<commit_message>
fix(slides): restore missing bullets in Part 2 slides
pptxgenjs wrote a stray <a:pPr><a:buNone/> after later runs in each
paragraph, so multi-run bullet points lost their bullet marker.

Co-Authored-By: Claude Opus 5.5 <noreply@anthropic.com>
</commit_message>
<xml_diff>
--- a/docs/final_slides/HWNet_Final_Presentation.pptx
+++ b/docs/final_slides/HWNet_Final_Presentation.pptx
@@ -5540,9 +5540,6 @@
               </a:rPr>
               <a:t>Matched receptive field:</a:t>
             </a:r>
-            <a:pPr indent="0" marL="0">
-              <a:buNone/>
-            </a:pPr>
             <a:r>
               <a:rPr lang="en-US" sz="1250" dirty="0">
                 <a:solidFill>
@@ -5551,9 +5548,6 @@
               </a:rPr>
               <a:t> a 1×3 kernel spans 3 windows, 0.5 s + 2 × 0.25 s = </a:t>
             </a:r>
-            <a:pPr indent="0" marL="0">
-              <a:buNone/>
-            </a:pPr>
             <a:r>
               <a:rPr lang="en-US" sz="1250" dirty="0">
                 <a:solidFill>
@@ -5562,9 +5556,6 @@
               </a:rPr>
               <a:t>1.0 s</a:t>
             </a:r>
-            <a:pPr indent="0" marL="0">
-              <a:buNone/>
-            </a:pPr>
             <a:r>
               <a:rPr lang="en-US" sz="1250" dirty="0">
                 <a:solidFill>
@@ -5591,9 +5582,6 @@
               </a:rPr>
               <a:t>Heavy regularization:</a:t>
             </a:r>
-            <a:pPr indent="0" marL="0">
-              <a:buNone/>
-            </a:pPr>
             <a:r>
               <a:rPr lang="en-US" sz="1250" dirty="0">
                 <a:solidFill>
@@ -5620,9 +5608,6 @@
               </a:rPr>
               <a:t>Single-task training:</a:t>
             </a:r>
-            <a:pPr indent="0" marL="0">
-              <a:buNone/>
-            </a:pPr>
             <a:r>
               <a:rPr lang="en-US" sz="1250" dirty="0">
                 <a:solidFill>
@@ -7256,9 +7241,6 @@
               </a:rPr>
               <a:t>Started from the first HWNet and changed </a:t>
             </a:r>
-            <a:pPr indent="0" marL="0">
-              <a:buNone/>
-            </a:pPr>
             <a:r>
               <a:rPr lang="en-US" sz="1250" dirty="0">
                 <a:solidFill>
@@ -7267,9 +7249,6 @@
               </a:rPr>
               <a:t>one setting at a time</a:t>
             </a:r>
-            <a:pPr indent="0" marL="0">
-              <a:buNone/>
-            </a:pPr>
             <a:r>
               <a:rPr lang="en-US" sz="1250" dirty="0">
                 <a:solidFill>
@@ -7296,9 +7275,6 @@
               </a:rPr>
               <a:t>Screened on 3 subjects (S01, S05, S08) × 5 folds, </a:t>
             </a:r>
-            <a:pPr indent="0" marL="0">
-              <a:buNone/>
-            </a:pPr>
             <a:r>
               <a:rPr lang="en-US" sz="1250" dirty="0">
                 <a:solidFill>
@@ -8792,9 +8768,6 @@
               </a:rPr>
               <a:t>k = 2 (0.75 s) is last on both metrics: </a:t>
             </a:r>
-            <a:pPr indent="0" marL="0">
-              <a:buNone/>
-            </a:pPr>
             <a:r>
               <a:rPr lang="en-US" sz="1250" dirty="0">
                 <a:solidFill>
@@ -9001,9 +8974,6 @@
               </a:rPr>
               <a:t>The top 3 are within </a:t>
             </a:r>
-            <a:pPr indent="0" marL="0">
-              <a:buNone/>
-            </a:pPr>
             <a:r>
               <a:rPr lang="en-US" sz="1250" dirty="0">
                 <a:solidFill>
@@ -9012,9 +8982,6 @@
               </a:rPr>
               <a:t>0.4 pp</a:t>
             </a:r>
-            <a:pPr indent="0" marL="0">
-              <a:buNone/>
-            </a:pPr>
             <a:r>
               <a:rPr lang="en-US" sz="1250" dirty="0">
                 <a:solidFill>
@@ -10315,9 +10282,6 @@
               </a:rPr>
               <a:t>Not significant</a:t>
             </a:r>
-            <a:pPr indent="0" marL="0">
-              <a:buNone/>
-            </a:pPr>
             <a:r>
               <a:rPr lang="en-US" sz="1250" dirty="0">
                 <a:solidFill>
@@ -10653,9 +10617,6 @@
               </a:rPr>
               <a:t>S05:</a:t>
             </a:r>
-            <a:pPr indent="0" marL="0">
-              <a:buNone/>
-            </a:pPr>
             <a:r>
               <a:rPr lang="en-US" sz="1250" dirty="0">
                 <a:solidFill>
@@ -10664,9 +10625,6 @@
               </a:rPr>
               <a:t> 78.6% vs 60.8% (</a:t>
             </a:r>
-            <a:pPr indent="0" marL="0">
-              <a:buNone/>
-            </a:pPr>
             <a:r>
               <a:rPr lang="en-US" sz="1250" dirty="0">
                 <a:solidFill>
@@ -10675,9 +10633,6 @@
               </a:rPr>
               <a:t>+17.8 pp</a:t>
             </a:r>
-            <a:pPr indent="0" marL="0">
-              <a:buNone/>
-            </a:pPr>
             <a:r>
               <a:rPr lang="en-US" sz="1250" dirty="0">
                 <a:solidFill>
@@ -10686,9 +10641,6 @@
               </a:rPr>
               <a:t>). Hypothesis: a short ERD burst that the 0.5 s windows keep </a:t>
             </a:r>
-            <a:pPr indent="0" marL="0">
-              <a:buNone/>
-            </a:pPr>
             <a:r>
               <a:rPr lang="en-US" sz="900" dirty="0">
                 <a:solidFill>
@@ -10715,9 +10667,6 @@
               </a:rPr>
               <a:t>S02:</a:t>
             </a:r>
-            <a:pPr indent="0" marL="0">
-              <a:buNone/>
-            </a:pPr>
             <a:r>
               <a:rPr lang="en-US" sz="1250" dirty="0">
                 <a:solidFill>
@@ -10744,9 +10693,6 @@
               </a:rPr>
               <a:t>Without S02:</a:t>
             </a:r>
-            <a:pPr indent="0" marL="0">
-              <a:buNone/>
-            </a:pPr>
             <a:r>
               <a:rPr lang="en-US" sz="1250" dirty="0">
                 <a:solidFill>
@@ -12180,9 +12126,6 @@
               </a:rPr>
               <a:t>Preprocessing does most of the work:</a:t>
             </a:r>
-            <a:pPr indent="0" marL="0">
-              <a:buNone/>
-            </a:pPr>
             <a:r>
               <a:rPr lang="en-US" sz="1300" dirty="0">
                 <a:solidFill>
@@ -12209,9 +12152,6 @@
               </a:rPr>
               <a:t>A 5,362-parameter CNN is enough:</a:t>
             </a:r>
-            <a:pPr indent="0" marL="0">
-              <a:buNone/>
-            </a:pPr>
             <a:r>
               <a:rPr lang="en-US" sz="1300" dirty="0">
                 <a:solidFill>
@@ -12238,9 +12178,6 @@
               </a:rPr>
               <a:t>Tuning confirmed the first design:</a:t>
             </a:r>
-            <a:pPr indent="0" marL="0">
-              <a:buNone/>
-            </a:pPr>
             <a:r>
               <a:rPr lang="en-US" sz="1300" dirty="0">
                 <a:solidFill>
@@ -12267,9 +12204,6 @@
               </a:rPr>
               <a:t>Cheap to train:</a:t>
             </a:r>
-            <a:pPr indent="0" marL="0">
-              <a:buNone/>
-            </a:pPr>
             <a:r>
               <a:rPr lang="en-US" sz="1300" dirty="0">
                 <a:solidFill>
@@ -12377,9 +12311,6 @@
               </a:rPr>
               <a:t>HWNet matches MixNet with ~8× fewer parameters and one loss. The accuracy gain is not significant, so the claim is </a:t>
             </a:r>
-            <a:pPr indent="0" marL="0">
-              <a:buNone/>
-            </a:pPr>
             <a:r>
               <a:rPr lang="en-US" sz="1300" dirty="0">
                 <a:solidFill>
@@ -12388,9 +12319,6 @@
               </a:rPr>
               <a:t>efficiency</a:t>
             </a:r>
-            <a:pPr indent="0" marL="0">
-              <a:buNone/>
-            </a:pPr>
             <a:r>
               <a:rPr lang="en-US" sz="1300" dirty="0">
                 <a:solidFill>

</xml_diff>

<commit_message>
docs(slides): add authors, unify page numbers, tidy tuning slide
- Authors on the title slide
- One page counter and progress bar across Part 1 and Part 2 (k/14)
- Comparison table wording: 7,200 -> 540 numbers, more lightweight
- Stage 1 slide: varied hyperparameters as a bullet list, clearer
  findings, best 4 sent to stage 2 as bullets

Co-Authored-By: Claude Opus 5.5 <noreply@anthropic.com>
</commit_message>
<xml_diff>
--- a/docs/final_slides/HWNet_Final_Presentation.pptx
+++ b/docs/final_slides/HWNet_Final_Presentation.pptx
@@ -3922,13 +3922,49 @@
       </p:sp>
       <p:sp>
         <p:nvSpPr>
+          <p:cNvPr id="5" name="Authors"/>
+          <p:cNvSpPr txBox="1"/>
+          <p:nvPr/>
+        </p:nvSpPr>
+        <p:spPr>
+          <a:xfrm>
+            <a:off x="548640" y="2651760"/>
+            <a:ext cx="8046720" cy="320040"/>
+          </a:xfrm>
+          <a:prstGeom prst="rect">
+            <a:avLst/>
+          </a:prstGeom>
+          <a:noFill/>
+          <a:ln/>
+        </p:spPr>
+        <p:txBody>
+          <a:bodyPr wrap="square" lIns="0" tIns="0" rIns="0" bIns="0" rtlCol="0" anchor="t"/>
+          <a:lstStyle/>
+          <a:p>
+            <a:pPr indent="0" marL="0">
+              <a:buNone/>
+            </a:pPr>
+            <a:r>
+              <a:rPr lang="en-US" sz="1300" dirty="0">
+                <a:solidFill>
+                  <a:schemeClr val="tx1"/>
+                </a:solidFill>
+              </a:rPr>
+              <a:t>Jiraphat Jamprasert, Pratch Piyawongwisal</a:t>
+            </a:r>
+            <a:endParaRPr lang="en-US" sz="1300" dirty="0"/>
+          </a:p>
+        </p:txBody>
+      </p:sp>
+      <p:sp>
+        <p:nvSpPr>
           <p:cNvPr id="4" name="Text 2"/>
           <p:cNvSpPr txBox="1"/>
           <p:nvPr/>
         </p:nvSpPr>
         <p:spPr>
           <a:xfrm>
-            <a:off x="548640" y="2651760"/>
+            <a:off x="548640" y="2971800"/>
             <a:ext cx="8046720" cy="320040"/>
           </a:xfrm>
           <a:prstGeom prst="rect">
@@ -4770,7 +4806,7 @@
         <p:spPr>
           <a:xfrm>
             <a:off x="0" y="502920"/>
-            <a:ext cx="1306286" cy="32004"/>
+            <a:ext cx="5225143" cy="32004"/>
           </a:xfrm>
           <a:prstGeom prst="rect">
             <a:avLst/>
@@ -4811,7 +4847,7 @@
                   <a:schemeClr val="tx1"/>
                 </a:solidFill>
               </a:rPr>
-              <a:t>1/7</a:t>
+              <a:t>8/14</a:t>
             </a:r>
             <a:endParaRPr lang="en-US" sz="900" dirty="0"/>
           </a:p>
@@ -5846,7 +5882,7 @@
         <p:spPr>
           <a:xfrm>
             <a:off x="0" y="502920"/>
-            <a:ext cx="2612571" cy="32004"/>
+            <a:ext cx="5878286" cy="32004"/>
           </a:xfrm>
           <a:prstGeom prst="rect">
             <a:avLst/>
@@ -5887,7 +5923,7 @@
                   <a:schemeClr val="tx1"/>
                 </a:solidFill>
               </a:rPr>
-              <a:t>2/7</a:t>
+              <a:t>9/14</a:t>
             </a:r>
             <a:endParaRPr lang="en-US" sz="900" dirty="0"/>
           </a:p>
@@ -6216,7 +6252,7 @@
                             <a:schemeClr val="tx1"/>
                           </a:solidFill>
                         </a:rPr>
-                        <a:t>540 vs 7,200 numbers</a:t>
+                        <a:t>7,200 → 540 numbers</a:t>
                       </a:r>
                       <a:endParaRPr lang="en-US" sz="1200" dirty="0"/>
                     </a:p>
@@ -6354,7 +6390,7 @@
                             <a:schemeClr val="tx1"/>
                           </a:solidFill>
                         </a:rPr>
-                        <a:t>less room to overfit</a:t>
+                        <a:t>more lightweight</a:t>
                       </a:r>
                       <a:endParaRPr lang="en-US" sz="1200" dirty="0"/>
                     </a:p>
@@ -7142,7 +7178,7 @@
         <p:spPr>
           <a:xfrm>
             <a:off x="0" y="502920"/>
-            <a:ext cx="3918857" cy="32004"/>
+            <a:ext cx="6531429" cy="32004"/>
           </a:xfrm>
           <a:prstGeom prst="rect">
             <a:avLst/>
@@ -7183,7 +7219,7 @@
                   <a:schemeClr val="tx1"/>
                 </a:solidFill>
               </a:rPr>
-              <a:t>3/7</a:t>
+              <a:t>10/14</a:t>
             </a:r>
             <a:endParaRPr lang="en-US" sz="900" dirty="0"/>
           </a:p>
@@ -7197,7 +7233,7 @@
         </p:nvGraphicFramePr>
         <p:xfrm>
           <a:off x="274320" y="640080"/>
-          <a:ext cx="5029200" cy="3657600"/>
+          <a:ext cx="4572000" cy="4023360"/>
         </p:xfrm>
         <a:graphic xmlns:a="http://schemas.openxmlformats.org/drawingml/2006/main">
           <a:graphicData uri="http://schemas.openxmlformats.org/drawingml/2006/chart">
@@ -7213,8 +7249,8 @@
         </p:nvSpPr>
         <p:spPr>
           <a:xfrm>
-            <a:off x="5486400" y="685800"/>
-            <a:ext cx="3246120" cy="2606040"/>
+            <a:off x="5029200" y="640080"/>
+            <a:ext cx="3703320" cy="2788920"/>
           </a:xfrm>
           <a:prstGeom prst="rect">
             <a:avLst/>
@@ -7228,21 +7264,21 @@
           <a:p>
             <a:pPr marL="152400" indent="-152400">
               <a:spcAft>
-                <a:spcPts val="600"/>
+                <a:spcPts val="200"/>
               </a:spcAft>
               <a:buSzPct val="100000"/>
               <a:buChar char="•"/>
             </a:pPr>
             <a:r>
-              <a:rPr lang="en-US" sz="1250" dirty="0">
+              <a:rPr lang="en-US" sz="1200" dirty="0">
                 <a:solidFill>
                   <a:schemeClr val="tx1"/>
                 </a:solidFill>
               </a:rPr>
-              <a:t>Started from the first HWNet and changed </a:t>
-            </a:r>
-            <a:r>
-              <a:rPr lang="en-US" sz="1250" dirty="0">
+              <a:t>Changed </a:t>
+            </a:r>
+            <a:r>
+              <a:rPr lang="en-US" sz="1200" dirty="0">
                 <a:solidFill>
                   <a:schemeClr val="accent4"/>
                 </a:solidFill>
@@ -7250,14 +7286,104 @@
               <a:t>one setting at a time</a:t>
             </a:r>
             <a:r>
-              <a:rPr lang="en-US" sz="1250" dirty="0">
+              <a:rPr lang="en-US" sz="1200" dirty="0">
                 <a:solidFill>
                   <a:schemeClr val="tx1"/>
                 </a:solidFill>
               </a:rPr>
-              <a:t>: kernel length k, dropout, learning rate, batch size, filter counts</a:t>
-            </a:r>
-            <a:endParaRPr lang="en-US" sz="1250" dirty="0"/>
+              <a:t> from the first HWNet:</a:t>
+            </a:r>
+            <a:endParaRPr lang="en-US" sz="1200" dirty="0"/>
+          </a:p>
+          <a:p>
+            <a:pPr lvl="1" marL="304800" indent="-152400">
+              <a:spcAft>
+                <a:spcPts val="200"/>
+              </a:spcAft>
+              <a:buSzPct val="100000"/>
+              <a:buChar char="–"/>
+            </a:pPr>
+            <a:r>
+              <a:rPr lang="en-US" sz="1200" dirty="0">
+                <a:solidFill>
+                  <a:schemeClr val="tx1"/>
+                </a:solidFill>
+              </a:rPr>
+              <a:t>kernel size k (2, 3, 5)</a:t>
+            </a:r>
+            <a:endParaRPr lang="en-US" sz="1200" dirty="0"/>
+          </a:p>
+          <a:p>
+            <a:pPr lvl="1" marL="304800" indent="-152400">
+              <a:spcAft>
+                <a:spcPts val="200"/>
+              </a:spcAft>
+              <a:buSzPct val="100000"/>
+              <a:buChar char="–"/>
+            </a:pPr>
+            <a:r>
+              <a:rPr lang="en-US" sz="1200" dirty="0">
+                <a:solidFill>
+                  <a:schemeClr val="tx1"/>
+                </a:solidFill>
+              </a:rPr>
+              <a:t>dropout (0.3, 0.5, 0.6)</a:t>
+            </a:r>
+            <a:endParaRPr lang="en-US" sz="1200" dirty="0"/>
+          </a:p>
+          <a:p>
+            <a:pPr lvl="1" marL="304800" indent="-152400">
+              <a:spcAft>
+                <a:spcPts val="200"/>
+              </a:spcAft>
+              <a:buSzPct val="100000"/>
+              <a:buChar char="–"/>
+            </a:pPr>
+            <a:r>
+              <a:rPr lang="en-US" sz="1200" dirty="0">
+                <a:solidFill>
+                  <a:schemeClr val="tx1"/>
+                </a:solidFill>
+              </a:rPr>
+              <a:t>learning rate (0.001, 0.0005, 0.0003)</a:t>
+            </a:r>
+            <a:endParaRPr lang="en-US" sz="1200" dirty="0"/>
+          </a:p>
+          <a:p>
+            <a:pPr lvl="1" marL="304800" indent="-152400">
+              <a:spcAft>
+                <a:spcPts val="200"/>
+              </a:spcAft>
+              <a:buSzPct val="100000"/>
+              <a:buChar char="–"/>
+            </a:pPr>
+            <a:r>
+              <a:rPr lang="en-US" sz="1200" dirty="0">
+                <a:solidFill>
+                  <a:schemeClr val="tx1"/>
+                </a:solidFill>
+              </a:rPr>
+              <a:t>batch size (32, 16)</a:t>
+            </a:r>
+            <a:endParaRPr lang="en-US" sz="1200" dirty="0"/>
+          </a:p>
+          <a:p>
+            <a:pPr lvl="1" marL="304800" indent="-152400">
+              <a:spcAft>
+                <a:spcPts val="200"/>
+              </a:spcAft>
+              <a:buSzPct val="100000"/>
+              <a:buChar char="–"/>
+            </a:pPr>
+            <a:r>
+              <a:rPr lang="en-US" sz="1200" dirty="0">
+                <a:solidFill>
+                  <a:schemeClr val="tx1"/>
+                </a:solidFill>
+              </a:rPr>
+              <a:t>filter counts (16/8, 32/16, 48/24)</a:t>
+            </a:r>
+            <a:endParaRPr lang="en-US" sz="1200" dirty="0"/>
           </a:p>
           <a:p>
             <a:pPr marL="152400" indent="-152400">
@@ -7268,22 +7394,22 @@
               <a:buChar char="•"/>
             </a:pPr>
             <a:r>
-              <a:rPr lang="en-US" sz="1250" dirty="0">
+              <a:rPr lang="en-US" sz="1200" dirty="0">
                 <a:solidFill>
                   <a:schemeClr val="tx1"/>
                 </a:solidFill>
               </a:rPr>
-              <a:t>Screened on 3 subjects (S01, S05, S08) × 5 folds, </a:t>
-            </a:r>
-            <a:r>
-              <a:rPr lang="en-US" sz="1250" dirty="0">
+              <a:t>Validated on 3 subjects (S01, S05, S08) × 5 folds of </a:t>
+            </a:r>
+            <a:r>
+              <a:rPr lang="en-US" sz="1200" dirty="0">
                 <a:solidFill>
                   <a:schemeClr val="accent4"/>
                 </a:solidFill>
               </a:rPr>
-              <a:t>session T validation only</a:t>
-            </a:r>
-            <a:endParaRPr lang="en-US" sz="1250" dirty="0"/>
+              <a:t>session T</a:t>
+            </a:r>
+            <a:endParaRPr lang="en-US" sz="1200" dirty="0"/>
           </a:p>
           <a:p>
             <a:pPr marL="152400" indent="-152400">
@@ -7294,27 +7420,45 @@
               <a:buChar char="•"/>
             </a:pPr>
             <a:r>
-              <a:rPr lang="en-US" sz="1250" dirty="0">
+              <a:rPr lang="en-US" sz="1200" dirty="0">
                 <a:solidFill>
                   <a:schemeClr val="tx1"/>
                 </a:solidFill>
               </a:rPr>
-              <a:t>Lower lr, smaller batch and 16/8 filters: all worse. 48/24 filters: close, but least stable across folds (SD 8.6 pp)</a:t>
-            </a:r>
-            <a:endParaRPr lang="en-US" sz="1250" dirty="0"/>
+              <a:t>Worse than baseline: lower lr, batch 16, 16/8 filters</a:t>
+            </a:r>
+            <a:endParaRPr lang="en-US" sz="1200" dirty="0"/>
+          </a:p>
+          <a:p>
+            <a:pPr marL="152400" indent="-152400">
+              <a:spcAft>
+                <a:spcPts val="600"/>
+              </a:spcAft>
+              <a:buSzPct val="100000"/>
+              <a:buChar char="•"/>
+            </a:pPr>
+            <a:r>
+              <a:rPr lang="en-US" sz="1200" dirty="0">
+                <a:solidFill>
+                  <a:schemeClr val="tx1"/>
+                </a:solidFill>
+              </a:rPr>
+              <a:t>48/24 filters: close, but least stable across folds</a:t>
+            </a:r>
+            <a:endParaRPr lang="en-US" sz="1200" dirty="0"/>
           </a:p>
         </p:txBody>
       </p:sp>
       <p:sp>
         <p:nvSpPr>
-          <p:cNvPr id="7" name="Sent to stage 2 (teal) body"/>
+          <p:cNvPr id="7" name="Pick best 4 for stage 2 body"/>
           <p:cNvSpPr/>
           <p:nvPr/>
         </p:nvSpPr>
         <p:spPr>
           <a:xfrm>
-            <a:off x="5486400" y="3474720"/>
-            <a:ext cx="3246120" cy="960120"/>
+            <a:off x="5029200" y="3520440"/>
+            <a:ext cx="3703320" cy="1143000"/>
           </a:xfrm>
           <a:prstGeom prst="rect">
             <a:avLst/>
@@ -7329,14 +7473,14 @@
       </p:sp>
       <p:sp>
         <p:nvSpPr>
-          <p:cNvPr id="8" name="Sent to stage 2 (teal) title"/>
+          <p:cNvPr id="8" name="Pick best 4 for stage 2 title"/>
           <p:cNvSpPr txBox="1"/>
           <p:nvPr/>
         </p:nvSpPr>
         <p:spPr>
           <a:xfrm>
-            <a:off x="5486400" y="3474720"/>
-            <a:ext cx="3246120" cy="274320"/>
+            <a:off x="5029200" y="3520440"/>
+            <a:ext cx="3703320" cy="274320"/>
           </a:xfrm>
           <a:prstGeom prst="rect">
             <a:avLst/>
@@ -7359,7 +7503,7 @@
                   <a:schemeClr val="bg2"/>
                 </a:solidFill>
               </a:rPr>
-              <a:t>Sent to stage 2 (teal)</a:t>
+              <a:t>Pick best 4 for stage 2</a:t>
             </a:r>
             <a:endParaRPr lang="en-US" sz="1300" dirty="0"/>
           </a:p>
@@ -7367,14 +7511,14 @@
       </p:sp>
       <p:sp>
         <p:nvSpPr>
-          <p:cNvPr id="9" name="Sent to stage 2 (teal) text"/>
+          <p:cNvPr id="9" name="Text 6"/>
           <p:cNvSpPr txBox="1"/>
           <p:nvPr/>
         </p:nvSpPr>
         <p:spPr>
           <a:xfrm>
-            <a:off x="5522976" y="3785616"/>
-            <a:ext cx="3172968" cy="612648"/>
+            <a:off x="5065776" y="3849624"/>
+            <a:ext cx="1815084" cy="457200"/>
           </a:xfrm>
           <a:prstGeom prst="rect">
             <a:avLst/>
@@ -7386,27 +7530,140 @@
           <a:bodyPr wrap="square" lIns="25400" tIns="50800" rIns="50800" bIns="25400" rtlCol="0" anchor="t"/>
           <a:lstStyle/>
           <a:p>
+            <a:pPr marL="152400" indent="-152400">
+              <a:spcAft>
+                <a:spcPts val="200"/>
+              </a:spcAft>
+              <a:buSzPct val="100000"/>
+              <a:buChar char="•"/>
+            </a:pPr>
+            <a:r>
+              <a:rPr lang="en-US" sz="1200" dirty="0">
+                <a:solidFill>
+                  <a:schemeClr val="tx1"/>
+                </a:solidFill>
+              </a:rPr>
+              <a:t>k = 2</a:t>
+            </a:r>
+            <a:endParaRPr lang="en-US" sz="1200" dirty="0"/>
+          </a:p>
+          <a:p>
+            <a:pPr marL="152400" indent="-152400">
+              <a:spcAft>
+                <a:spcPts val="200"/>
+              </a:spcAft>
+              <a:buSzPct val="100000"/>
+              <a:buChar char="•"/>
+            </a:pPr>
+            <a:r>
+              <a:rPr lang="en-US" sz="1200" dirty="0">
+                <a:solidFill>
+                  <a:schemeClr val="tx1"/>
+                </a:solidFill>
+              </a:rPr>
+              <a:t>k = 3 (baseline)</a:t>
+            </a:r>
+            <a:endParaRPr lang="en-US" sz="1200" dirty="0"/>
+          </a:p>
+        </p:txBody>
+      </p:sp>
+      <p:sp>
+        <p:nvSpPr>
+          <p:cNvPr id="10" name="Text 7"/>
+          <p:cNvSpPr txBox="1"/>
+          <p:nvPr/>
+        </p:nvSpPr>
+        <p:spPr>
+          <a:xfrm>
+            <a:off x="6880860" y="3849624"/>
+            <a:ext cx="1815084" cy="457200"/>
+          </a:xfrm>
+          <a:prstGeom prst="rect">
+            <a:avLst/>
+          </a:prstGeom>
+          <a:noFill/>
+          <a:ln/>
+        </p:spPr>
+        <p:txBody>
+          <a:bodyPr wrap="square" lIns="25400" tIns="50800" rIns="50800" bIns="25400" rtlCol="0" anchor="t"/>
+          <a:lstStyle/>
+          <a:p>
+            <a:pPr marL="152400" indent="-152400">
+              <a:spcAft>
+                <a:spcPts val="200"/>
+              </a:spcAft>
+              <a:buSzPct val="100000"/>
+              <a:buChar char="•"/>
+            </a:pPr>
+            <a:r>
+              <a:rPr lang="en-US" sz="1200" dirty="0">
+                <a:solidFill>
+                  <a:schemeClr val="tx1"/>
+                </a:solidFill>
+              </a:rPr>
+              <a:t>k = 5</a:t>
+            </a:r>
+            <a:endParaRPr lang="en-US" sz="1200" dirty="0"/>
+          </a:p>
+          <a:p>
+            <a:pPr marL="152400" indent="-152400">
+              <a:spcAft>
+                <a:spcPts val="200"/>
+              </a:spcAft>
+              <a:buSzPct val="100000"/>
+              <a:buChar char="•"/>
+            </a:pPr>
+            <a:r>
+              <a:rPr lang="en-US" sz="1200" dirty="0">
+                <a:solidFill>
+                  <a:schemeClr val="tx1"/>
+                </a:solidFill>
+              </a:rPr>
+              <a:t>dropout 0.6</a:t>
+            </a:r>
+            <a:endParaRPr lang="en-US" sz="1200" dirty="0"/>
+          </a:p>
+        </p:txBody>
+      </p:sp>
+      <p:sp>
+        <p:nvSpPr>
+          <p:cNvPr id="11" name="Text 8"/>
+          <p:cNvSpPr txBox="1"/>
+          <p:nvPr/>
+        </p:nvSpPr>
+        <p:spPr>
+          <a:xfrm>
+            <a:off x="5065776" y="4325112"/>
+            <a:ext cx="3630168" cy="274320"/>
+          </a:xfrm>
+          <a:prstGeom prst="rect">
+            <a:avLst/>
+          </a:prstGeom>
+          <a:noFill/>
+          <a:ln/>
+        </p:spPr>
+        <p:txBody>
+          <a:bodyPr wrap="square" lIns="25400" tIns="50800" rIns="50800" bIns="25400" rtlCol="0" anchor="t"/>
+          <a:lstStyle/>
+          <a:p>
             <a:pPr indent="0" marL="0">
-              <a:spcAft>
-                <a:spcPts val="500"/>
-              </a:spcAft>
               <a:buNone/>
             </a:pPr>
             <a:r>
-              <a:rPr lang="en-US" sz="1250" dirty="0">
-                <a:solidFill>
-                  <a:schemeClr val="tx1"/>
-                </a:solidFill>
-              </a:rPr>
-              <a:t>k = 2, 3, 5 and dropout 0.5, 0.6: all within 0.7 pp of the baseline</a:t>
-            </a:r>
-            <a:endParaRPr lang="en-US" sz="1250" dirty="0"/>
+              <a:rPr lang="en-US" sz="1050" dirty="0">
+                <a:solidFill>
+                  <a:schemeClr val="tx2"/>
+                </a:solidFill>
+              </a:rPr>
+              <a:t>plus one combination: k = 2 with dropout 0.6</a:t>
+            </a:r>
+            <a:endParaRPr lang="en-US" sz="1050" dirty="0"/>
           </a:p>
         </p:txBody>
       </p:sp>
       <p:sp>
         <p:nvSpPr>
-          <p:cNvPr id="10" name="Text 7"/>
+          <p:cNvPr id="12" name="Text 9"/>
           <p:cNvSpPr txBox="1"/>
           <p:nvPr/>
         </p:nvSpPr>
@@ -7434,7 +7691,7 @@
                   <a:schemeClr val="tx1"/>
                 </a:solidFill>
               </a:rPr>
-              <a:t>Mean validation accuracy over 15 folds (S01, S05, S08), session T. Session E not used.</a:t>
+              <a:t>Mean validation accuracy over 15 folds (S01, S05, S08), session T. Session E not used. Highlighted bars: sent to stage 2.</a:t>
             </a:r>
             <a:endParaRPr lang="en-US" sz="900" dirty="0"/>
           </a:p>
@@ -7497,7 +7754,7 @@
                   <a:schemeClr val="bg1"/>
                 </a:solidFill>
               </a:rPr>
-              <a:t>Tuning, stage 2: top 5 on all 9 subjects, picked on validation</a:t>
+              <a:t>Tuning, stage 2: 5 candidates on all 9 subjects, picked on validation</a:t>
             </a:r>
             <a:endParaRPr lang="en-US" sz="1800" dirty="0"/>
           </a:p>
@@ -7512,7 +7769,7 @@
         <p:spPr>
           <a:xfrm>
             <a:off x="0" y="502920"/>
-            <a:ext cx="5225143" cy="32004"/>
+            <a:ext cx="7184571" cy="32004"/>
           </a:xfrm>
           <a:prstGeom prst="rect">
             <a:avLst/>
@@ -7553,7 +7810,7 @@
                   <a:schemeClr val="tx1"/>
                 </a:solidFill>
               </a:rPr>
-              <a:t>4/7</a:t>
+              <a:t>11/14</a:t>
             </a:r>
             <a:endParaRPr lang="en-US" sz="900" dirty="0"/>
           </a:p>
@@ -9102,7 +9359,7 @@
         <p:spPr>
           <a:xfrm>
             <a:off x="0" y="502920"/>
-            <a:ext cx="6531429" cy="32004"/>
+            <a:ext cx="7837714" cy="32004"/>
           </a:xfrm>
           <a:prstGeom prst="rect">
             <a:avLst/>
@@ -9143,7 +9400,7 @@
                   <a:schemeClr val="tx1"/>
                 </a:solidFill>
               </a:rPr>
-              <a:t>5/7</a:t>
+              <a:t>12/14</a:t>
             </a:r>
             <a:endParaRPr lang="en-US" sz="900" dirty="0"/>
           </a:p>
@@ -10518,7 +10775,7 @@
         <p:spPr>
           <a:xfrm>
             <a:off x="0" y="502920"/>
-            <a:ext cx="7837714" cy="32004"/>
+            <a:ext cx="8490857" cy="32004"/>
           </a:xfrm>
           <a:prstGeom prst="rect">
             <a:avLst/>
@@ -10559,7 +10816,7 @@
                   <a:schemeClr val="tx1"/>
                 </a:solidFill>
               </a:rPr>
-              <a:t>6/7</a:t>
+              <a:t>13/14</a:t>
             </a:r>
             <a:endParaRPr lang="en-US" sz="900" dirty="0"/>
           </a:p>
@@ -10912,7 +11169,7 @@
         <p:spPr>
           <a:xfrm>
             <a:off x="0" y="502920"/>
-            <a:ext cx="1828800" cy="32004"/>
+            <a:ext cx="1306286" cy="32004"/>
           </a:xfrm>
           <a:prstGeom prst="rect">
             <a:avLst/>
@@ -10953,7 +11210,7 @@
                   <a:schemeClr val="tx1"/>
                 </a:solidFill>
               </a:rPr>
-              <a:t>1/5</a:t>
+              <a:t>2/14</a:t>
             </a:r>
             <a:endParaRPr lang="en-US" sz="900" dirty="0"/>
           </a:p>
@@ -12084,7 +12341,7 @@
                   <a:schemeClr val="tx1"/>
                 </a:solidFill>
               </a:rPr>
-              <a:t>7/7</a:t>
+              <a:t>14/14</a:t>
             </a:r>
             <a:endParaRPr lang="en-US" sz="900" dirty="0"/>
           </a:p>
@@ -17063,7 +17320,7 @@
         <p:spPr>
           <a:xfrm>
             <a:off x="0" y="502920"/>
-            <a:ext cx="3657600" cy="32004"/>
+            <a:ext cx="1959429" cy="32004"/>
           </a:xfrm>
           <a:prstGeom prst="rect">
             <a:avLst/>
@@ -17104,7 +17361,7 @@
                   <a:schemeClr val="tx1"/>
                 </a:solidFill>
               </a:rPr>
-              <a:t>2/5</a:t>
+              <a:t>3/14</a:t>
             </a:r>
             <a:endParaRPr lang="en-US" sz="900" dirty="0"/>
           </a:p>
@@ -18183,7 +18440,7 @@
         <p:spPr>
           <a:xfrm>
             <a:off x="0" y="502920"/>
-            <a:ext cx="5486400" cy="32004"/>
+            <a:ext cx="2612571" cy="32004"/>
           </a:xfrm>
           <a:prstGeom prst="rect">
             <a:avLst/>
@@ -18224,7 +18481,7 @@
                   <a:schemeClr val="tx1"/>
                 </a:solidFill>
               </a:rPr>
-              <a:t>3/5</a:t>
+              <a:t>4/14</a:t>
             </a:r>
             <a:endParaRPr lang="en-US" sz="900" dirty="0"/>
           </a:p>
@@ -18614,7 +18871,7 @@
         <p:spPr>
           <a:xfrm>
             <a:off x="0" y="502920"/>
-            <a:ext cx="7315200" cy="32004"/>
+            <a:ext cx="3265714" cy="32004"/>
           </a:xfrm>
           <a:prstGeom prst="rect">
             <a:avLst/>
@@ -18655,7 +18912,7 @@
                   <a:schemeClr val="tx1"/>
                 </a:solidFill>
               </a:rPr>
-              <a:t>4/5</a:t>
+              <a:t>5/14</a:t>
             </a:r>
             <a:endParaRPr lang="en-US" sz="900" dirty="0"/>
           </a:p>
@@ -19012,7 +19269,7 @@
         <p:spPr>
           <a:xfrm>
             <a:off x="0" y="502920"/>
-            <a:ext cx="9144000" cy="32004"/>
+            <a:ext cx="3918857" cy="32004"/>
           </a:xfrm>
           <a:prstGeom prst="rect">
             <a:avLst/>
@@ -19053,7 +19310,7 @@
                   <a:schemeClr val="tx1"/>
                 </a:solidFill>
               </a:rPr>
-              <a:t>5/5</a:t>
+              <a:t>6/14</a:t>
             </a:r>
             <a:endParaRPr lang="en-US" sz="900" dirty="0"/>
           </a:p>

</xml_diff>

<commit_message>
docs(slides): trim Part 2 notes and boxes, add dataset-size takeaway
- Stage 1: best 5 sent to stage 2 as bullets, footnote removed
- Stage 2: shorter title and selection rule
- Results: drop run-to-run noise box and footnotes
- Per subject: drop untested S05 hypothesis and footnote
- Takeaways: add small-dataset point, plainer wording,
  "Future improvements" box

Co-Authored-By: Claude Opus 5.5 <noreply@anthropic.com>
</commit_message>
<xml_diff>
--- a/docs/final_slides/HWNet_Final_Presentation.pptx
+++ b/docs/final_slides/HWNet_Final_Presentation.pptx
@@ -7451,14 +7451,14 @@
       </p:sp>
       <p:sp>
         <p:nvSpPr>
-          <p:cNvPr id="7" name="Pick best 4 for stage 2 body"/>
+          <p:cNvPr id="7" name="Pick best 5 for stage 2 body"/>
           <p:cNvSpPr/>
           <p:nvPr/>
         </p:nvSpPr>
         <p:spPr>
           <a:xfrm>
             <a:off x="5029200" y="3520440"/>
-            <a:ext cx="3703320" cy="1143000"/>
+            <a:ext cx="3703320" cy="1097280"/>
           </a:xfrm>
           <a:prstGeom prst="rect">
             <a:avLst/>
@@ -7473,7 +7473,7 @@
       </p:sp>
       <p:sp>
         <p:nvSpPr>
-          <p:cNvPr id="8" name="Pick best 4 for stage 2 title"/>
+          <p:cNvPr id="8" name="Pick best 5 for stage 2 title"/>
           <p:cNvSpPr txBox="1"/>
           <p:nvPr/>
         </p:nvSpPr>
@@ -7503,7 +7503,7 @@
                   <a:schemeClr val="bg2"/>
                 </a:solidFill>
               </a:rPr>
-              <a:t>Pick best 4 for stage 2</a:t>
+              <a:t>Pick best 5 for stage 2</a:t>
             </a:r>
             <a:endParaRPr lang="en-US" sz="1300" dirty="0"/>
           </a:p>
@@ -7518,7 +7518,7 @@
         <p:spPr>
           <a:xfrm>
             <a:off x="5065776" y="3849624"/>
-            <a:ext cx="1815084" cy="457200"/>
+            <a:ext cx="1815084" cy="731520"/>
           </a:xfrm>
           <a:prstGeom prst="rect">
             <a:avLst/>
@@ -7565,6 +7565,24 @@
             </a:r>
             <a:endParaRPr lang="en-US" sz="1200" dirty="0"/>
           </a:p>
+          <a:p>
+            <a:pPr marL="152400" indent="-152400">
+              <a:spcAft>
+                <a:spcPts val="200"/>
+              </a:spcAft>
+              <a:buSzPct val="100000"/>
+              <a:buChar char="•"/>
+            </a:pPr>
+            <a:r>
+              <a:rPr lang="en-US" sz="1200" dirty="0">
+                <a:solidFill>
+                  <a:schemeClr val="tx1"/>
+                </a:solidFill>
+              </a:rPr>
+              <a:t>k = 5</a:t>
+            </a:r>
+            <a:endParaRPr lang="en-US" sz="1200" dirty="0"/>
+          </a:p>
         </p:txBody>
       </p:sp>
       <p:sp>
@@ -7576,7 +7594,7 @@
         <p:spPr>
           <a:xfrm>
             <a:off x="6880860" y="3849624"/>
-            <a:ext cx="1815084" cy="457200"/>
+            <a:ext cx="1815084" cy="731520"/>
           </a:xfrm>
           <a:prstGeom prst="rect">
             <a:avLst/>
@@ -7601,7 +7619,7 @@
                   <a:schemeClr val="tx1"/>
                 </a:solidFill>
               </a:rPr>
-              <a:t>k = 5</a:t>
+              <a:t>dropout 0.6</a:t>
             </a:r>
             <a:endParaRPr lang="en-US" sz="1200" dirty="0"/>
           </a:p>
@@ -7619,81 +7637,9 @@
                   <a:schemeClr val="tx1"/>
                 </a:solidFill>
               </a:rPr>
-              <a:t>dropout 0.6</a:t>
+              <a:t>k = 2 + dropout 0.6</a:t>
             </a:r>
             <a:endParaRPr lang="en-US" sz="1200" dirty="0"/>
-          </a:p>
-        </p:txBody>
-      </p:sp>
-      <p:sp>
-        <p:nvSpPr>
-          <p:cNvPr id="11" name="Text 8"/>
-          <p:cNvSpPr txBox="1"/>
-          <p:nvPr/>
-        </p:nvSpPr>
-        <p:spPr>
-          <a:xfrm>
-            <a:off x="5065776" y="4325112"/>
-            <a:ext cx="3630168" cy="274320"/>
-          </a:xfrm>
-          <a:prstGeom prst="rect">
-            <a:avLst/>
-          </a:prstGeom>
-          <a:noFill/>
-          <a:ln/>
-        </p:spPr>
-        <p:txBody>
-          <a:bodyPr wrap="square" lIns="25400" tIns="50800" rIns="50800" bIns="25400" rtlCol="0" anchor="t"/>
-          <a:lstStyle/>
-          <a:p>
-            <a:pPr indent="0" marL="0">
-              <a:buNone/>
-            </a:pPr>
-            <a:r>
-              <a:rPr lang="en-US" sz="1050" dirty="0">
-                <a:solidFill>
-                  <a:schemeClr val="tx2"/>
-                </a:solidFill>
-              </a:rPr>
-              <a:t>plus one combination: k = 2 with dropout 0.6</a:t>
-            </a:r>
-            <a:endParaRPr lang="en-US" sz="1050" dirty="0"/>
-          </a:p>
-        </p:txBody>
-      </p:sp>
-      <p:sp>
-        <p:nvSpPr>
-          <p:cNvPr id="12" name="Text 9"/>
-          <p:cNvSpPr txBox="1"/>
-          <p:nvPr/>
-        </p:nvSpPr>
-        <p:spPr>
-          <a:xfrm>
-            <a:off x="365760" y="4773168"/>
-            <a:ext cx="7315200" cy="228600"/>
-          </a:xfrm>
-          <a:prstGeom prst="rect">
-            <a:avLst/>
-          </a:prstGeom>
-          <a:noFill/>
-          <a:ln/>
-        </p:spPr>
-        <p:txBody>
-          <a:bodyPr wrap="square" lIns="0" tIns="0" rIns="0" bIns="0" rtlCol="0" anchor="t"/>
-          <a:lstStyle/>
-          <a:p>
-            <a:pPr indent="0" marL="0">
-              <a:buNone/>
-            </a:pPr>
-            <a:r>
-              <a:rPr lang="en-US" sz="900" dirty="0">
-                <a:solidFill>
-                  <a:schemeClr val="tx1"/>
-                </a:solidFill>
-              </a:rPr>
-              <a:t>Mean validation accuracy over 15 folds (S01, S05, S08), session T. Session E not used. Highlighted bars: sent to stage 2.</a:t>
-            </a:r>
-            <a:endParaRPr lang="en-US" sz="900" dirty="0"/>
           </a:p>
         </p:txBody>
       </p:sp>
@@ -7754,7 +7700,7 @@
                   <a:schemeClr val="bg1"/>
                 </a:solidFill>
               </a:rPr>
-              <a:t>Tuning, stage 2: 5 candidates on all 9 subjects, picked on validation</a:t>
+              <a:t>Tuning, stage 2: 5 candidates on all 9 subjects</a:t>
             </a:r>
             <a:endParaRPr lang="en-US" sz="1800" dirty="0"/>
           </a:p>
@@ -9046,7 +8992,7 @@
         <p:spPr>
           <a:xfrm>
             <a:off x="5669280" y="777240"/>
-            <a:ext cx="3063240" cy="1417320"/>
+            <a:ext cx="3063240" cy="960120"/>
           </a:xfrm>
           <a:prstGeom prst="rect">
             <a:avLst/>
@@ -9106,7 +9052,7 @@
         <p:spPr>
           <a:xfrm>
             <a:off x="5705856" y="1088136"/>
-            <a:ext cx="2990088" cy="1069848"/>
+            <a:ext cx="2990088" cy="612648"/>
           </a:xfrm>
           <a:prstGeom prst="rect">
             <a:avLst/>
@@ -9130,7 +9076,7 @@
                   <a:schemeClr val="tx1"/>
                 </a:solidFill>
               </a:rPr>
-              <a:t>Highest mean validation macro-F1 over 9 subjects × 5 folds of session T, with accuracy as a check. Session E is not used to choose.</a:t>
+              <a:t>Highest mean validation macro-F1 over 9 subjects × 5 folds of session T.</a:t>
             </a:r>
             <a:endParaRPr lang="en-US" sz="1250" dirty="0"/>
           </a:p>
@@ -9144,7 +9090,7 @@
         </p:nvSpPr>
         <p:spPr>
           <a:xfrm>
-            <a:off x="5669280" y="2423160"/>
+            <a:off x="5669280" y="1965960"/>
             <a:ext cx="3063240" cy="1234440"/>
           </a:xfrm>
           <a:prstGeom prst="rect">
@@ -9166,7 +9112,7 @@
         </p:nvSpPr>
         <p:spPr>
           <a:xfrm>
-            <a:off x="5669280" y="2423160"/>
+            <a:off x="5669280" y="1965960"/>
             <a:ext cx="3063240" cy="274320"/>
           </a:xfrm>
           <a:prstGeom prst="rect">
@@ -9204,7 +9150,7 @@
         </p:nvSpPr>
         <p:spPr>
           <a:xfrm>
-            <a:off x="5705856" y="2734056"/>
+            <a:off x="5705856" y="2276856"/>
             <a:ext cx="2990088" cy="886968"/>
           </a:xfrm>
           <a:prstGeom prst="rect">
@@ -10398,7 +10344,7 @@
         <p:spPr>
           <a:xfrm>
             <a:off x="411480" y="2514600"/>
-            <a:ext cx="4480560" cy="1600200"/>
+            <a:ext cx="8321040" cy="1463040"/>
           </a:xfrm>
           <a:prstGeom prst="rect">
             <a:avLst/>
@@ -10420,7 +10366,7 @@
         <p:spPr>
           <a:xfrm>
             <a:off x="411480" y="2514600"/>
-            <a:ext cx="4480560" cy="274320"/>
+            <a:ext cx="8321040" cy="274320"/>
           </a:xfrm>
           <a:prstGeom prst="rect">
             <a:avLst/>
@@ -10458,7 +10404,7 @@
         <p:spPr>
           <a:xfrm>
             <a:off x="448056" y="2825496"/>
-            <a:ext cx="4407408" cy="1252728"/>
+            <a:ext cx="8247888" cy="1115568"/>
           </a:xfrm>
           <a:prstGeom prst="rect">
             <a:avLst/>
@@ -10548,158 +10494,6 @@
               <a:t> with 9 subjects</a:t>
             </a:r>
             <a:endParaRPr lang="en-US" sz="1250" dirty="0"/>
-          </a:p>
-        </p:txBody>
-      </p:sp>
-      <p:sp>
-        <p:nvSpPr>
-          <p:cNvPr id="9" name="Run-to-run noise body"/>
-          <p:cNvSpPr/>
-          <p:nvPr/>
-        </p:nvSpPr>
-        <p:spPr>
-          <a:xfrm>
-            <a:off x="5120640" y="2514600"/>
-            <a:ext cx="3611880" cy="1600200"/>
-          </a:xfrm>
-          <a:prstGeom prst="rect">
-            <a:avLst/>
-          </a:prstGeom>
-          <a:solidFill>
-            <a:schemeClr val="accent3">
-              <a:alpha val="8000"/>
-            </a:schemeClr>
-          </a:solidFill>
-          <a:ln/>
-        </p:spPr>
-      </p:sp>
-      <p:sp>
-        <p:nvSpPr>
-          <p:cNvPr id="10" name="Run-to-run noise title"/>
-          <p:cNvSpPr txBox="1"/>
-          <p:nvPr/>
-        </p:nvSpPr>
-        <p:spPr>
-          <a:xfrm>
-            <a:off x="5120640" y="2514600"/>
-            <a:ext cx="3611880" cy="274320"/>
-          </a:xfrm>
-          <a:prstGeom prst="rect">
-            <a:avLst/>
-          </a:prstGeom>
-          <a:solidFill>
-            <a:schemeClr val="accent3"/>
-          </a:solidFill>
-          <a:ln/>
-        </p:spPr>
-        <p:txBody>
-          <a:bodyPr wrap="square" lIns="76200" tIns="0" rIns="76200" bIns="0" rtlCol="0" anchor="ctr"/>
-          <a:lstStyle/>
-          <a:p>
-            <a:pPr indent="0" marL="0">
-              <a:buNone/>
-            </a:pPr>
-            <a:r>
-              <a:rPr lang="en-US" sz="1300" b="1" dirty="0">
-                <a:solidFill>
-                  <a:schemeClr val="bg2"/>
-                </a:solidFill>
-              </a:rPr>
-              <a:t>Run-to-run noise</a:t>
-            </a:r>
-            <a:endParaRPr lang="en-US" sz="1300" dirty="0"/>
-          </a:p>
-        </p:txBody>
-      </p:sp>
-      <p:sp>
-        <p:nvSpPr>
-          <p:cNvPr id="11" name="Run-to-run noise text"/>
-          <p:cNvSpPr txBox="1"/>
-          <p:nvPr/>
-        </p:nvSpPr>
-        <p:spPr>
-          <a:xfrm>
-            <a:off x="5157216" y="2825496"/>
-            <a:ext cx="3538728" cy="1252728"/>
-          </a:xfrm>
-          <a:prstGeom prst="rect">
-            <a:avLst/>
-          </a:prstGeom>
-          <a:noFill/>
-          <a:ln/>
-        </p:spPr>
-        <p:txBody>
-          <a:bodyPr wrap="square" lIns="25400" tIns="50800" rIns="50800" bIns="25400" rtlCol="0" anchor="t"/>
-          <a:lstStyle/>
-          <a:p>
-            <a:pPr indent="0" marL="0">
-              <a:spcAft>
-                <a:spcPts val="500"/>
-              </a:spcAft>
-              <a:buNone/>
-            </a:pPr>
-            <a:r>
-              <a:rPr lang="en-US" sz="1250" dirty="0">
-                <a:solidFill>
-                  <a:schemeClr val="tx1"/>
-                </a:solidFill>
-              </a:rPr>
-              <a:t>The same k = 3 setup, trained twice: 77.13% then 78.33% (+1.2 pp).</a:t>
-            </a:r>
-            <a:endParaRPr lang="en-US" sz="1250" dirty="0"/>
-          </a:p>
-          <a:p>
-            <a:pPr indent="0" marL="0">
-              <a:spcAft>
-                <a:spcPts val="500"/>
-              </a:spcAft>
-              <a:buNone/>
-            </a:pPr>
-            <a:r>
-              <a:rPr lang="en-US" sz="1250" dirty="0">
-                <a:solidFill>
-                  <a:schemeClr val="tx1"/>
-                </a:solidFill>
-              </a:rPr>
-              <a:t>So gaps under ~1 pp, like k = 5 vs k = 3 (+0.3 pp), are within noise.</a:t>
-            </a:r>
-            <a:endParaRPr lang="en-US" sz="1250" dirty="0"/>
-          </a:p>
-        </p:txBody>
-      </p:sp>
-      <p:sp>
-        <p:nvSpPr>
-          <p:cNvPr id="12" name="Text 9"/>
-          <p:cNvSpPr txBox="1"/>
-          <p:nvPr/>
-        </p:nvSpPr>
-        <p:spPr>
-          <a:xfrm>
-            <a:off x="365760" y="4773168"/>
-            <a:ext cx="7315200" cy="228600"/>
-          </a:xfrm>
-          <a:prstGeom prst="rect">
-            <a:avLst/>
-          </a:prstGeom>
-          <a:noFill/>
-          <a:ln/>
-        </p:spPr>
-        <p:txBody>
-          <a:bodyPr wrap="square" lIns="0" tIns="0" rIns="0" bIns="0" rtlCol="0" anchor="t"/>
-          <a:lstStyle/>
-          <a:p>
-            <a:pPr indent="0" marL="0">
-              <a:buNone/>
-            </a:pPr>
-            <a:r>
-              <a:rPr lang="en-US" sz="900" dirty="0">
-                <a:solidFill>
-                  <a:schemeClr val="tx1"/>
-                </a:solidFill>
-              </a:rPr>
-              <a:t>± = SD over 9 subjects. Session E is the held-out test session; it is used only here and on the next slide.</a:t>
-            </a:r>
-            <a:endParaRPr lang="en-US" sz="900" dirty="0"/>
           </a:p>
         </p:txBody>
       </p:sp>
@@ -10896,15 +10690,7 @@
                   <a:schemeClr val="tx1"/>
                 </a:solidFill>
               </a:rPr>
-              <a:t>). Hypothesis: a short ERD burst that the 0.5 s windows keep </a:t>
-            </a:r>
-            <a:r>
-              <a:rPr lang="en-US" sz="900" dirty="0">
-                <a:solidFill>
-                  <a:schemeClr val="tx2"/>
-                </a:solidFill>
-              </a:rPr>
-              <a:t> not tested yet</a:t>
+              <a:t>)</a:t>
             </a:r>
             <a:endParaRPr lang="en-US" sz="1250" dirty="0"/>
           </a:p>
@@ -11058,42 +10844,6 @@
               <a:t>The mean gain comes from S05. Without S05, HWNet is 0.2 pp below MixNet.</a:t>
             </a:r>
             <a:endParaRPr lang="en-US" sz="1250" dirty="0"/>
-          </a:p>
-        </p:txBody>
-      </p:sp>
-      <p:sp>
-        <p:nvSpPr>
-          <p:cNvPr id="10" name="Text 7"/>
-          <p:cNvSpPr txBox="1"/>
-          <p:nvPr/>
-        </p:nvSpPr>
-        <p:spPr>
-          <a:xfrm>
-            <a:off x="365760" y="4773168"/>
-            <a:ext cx="7315200" cy="228600"/>
-          </a:xfrm>
-          <a:prstGeom prst="rect">
-            <a:avLst/>
-          </a:prstGeom>
-          <a:noFill/>
-          <a:ln/>
-        </p:spPr>
-        <p:txBody>
-          <a:bodyPr wrap="square" lIns="0" tIns="0" rIns="0" bIns="0" rtlCol="0" anchor="t"/>
-          <a:lstStyle/>
-          <a:p>
-            <a:pPr indent="0" marL="0">
-              <a:buNone/>
-            </a:pPr>
-            <a:r>
-              <a:rPr lang="en-US" sz="900" dirty="0">
-                <a:solidFill>
-                  <a:schemeClr val="tx1"/>
-                </a:solidFill>
-              </a:rPr>
-              <a:t>Session E test accuracy, selected HWNet (k = 3) minus MixNet. Teal: HWNet higher, gold: MixNet higher.</a:t>
-            </a:r>
-            <a:endParaRPr lang="en-US" sz="900" dirty="0"/>
           </a:p>
         </p:txBody>
       </p:sp>
@@ -12471,6 +12221,32 @@
             </a:r>
             <a:endParaRPr lang="en-US" sz="1300" dirty="0"/>
           </a:p>
+          <a:p>
+            <a:pPr marL="152400" indent="-152400">
+              <a:spcAft>
+                <a:spcPts val="800"/>
+              </a:spcAft>
+              <a:buSzPct val="100000"/>
+              <a:buChar char="•"/>
+            </a:pPr>
+            <a:r>
+              <a:rPr lang="en-US" sz="1300" b="1" dirty="0">
+                <a:solidFill>
+                  <a:schemeClr val="tx1"/>
+                </a:solidFill>
+              </a:rPr>
+              <a:t>Small dataset:</a:t>
+            </a:r>
+            <a:r>
+              <a:rPr lang="en-US" sz="1300" dirty="0">
+                <a:solidFill>
+                  <a:schemeClr val="tx1"/>
+                </a:solidFill>
+              </a:rPr>
+              <a:t> only 9 subjects and ~115 training trials per fold, so we still need to test on a larger, more challenging dataset</a:t>
+            </a:r>
+            <a:endParaRPr lang="en-US" sz="1300" dirty="0"/>
+          </a:p>
         </p:txBody>
       </p:sp>
       <p:sp>
@@ -12566,7 +12342,7 @@
                   <a:schemeClr val="tx1"/>
                 </a:solidFill>
               </a:rPr>
-              <a:t>HWNet matches MixNet with ~8× fewer parameters and one loss. The accuracy gain is not significant, so the claim is </a:t>
+              <a:t>HWNet gets about the same accuracy as MixNet with ~8× fewer parameters and one loss. The +1.8 pp gain is not statistically significant, so the real win is a </a:t>
             </a:r>
             <a:r>
               <a:rPr lang="en-US" sz="1300" dirty="0">
@@ -12574,7 +12350,7 @@
                   <a:schemeClr val="accent4"/>
                 </a:solidFill>
               </a:rPr>
-              <a:t>efficiency</a:t>
+              <a:t>smaller, faster model</a:t>
             </a:r>
             <a:r>
               <a:rPr lang="en-US" sz="1300" dirty="0">
@@ -12582,7 +12358,7 @@
                   <a:schemeClr val="tx1"/>
                 </a:solidFill>
               </a:rPr>
-              <a:t>, not better accuracy.</a:t>
+              <a:t>.</a:t>
             </a:r>
             <a:endParaRPr lang="en-US" sz="1300" dirty="0"/>
           </a:p>
@@ -12590,7 +12366,7 @@
       </p:sp>
       <p:sp>
         <p:nvSpPr>
-          <p:cNvPr id="9" name="Next body"/>
+          <p:cNvPr id="9" name="Future improvements body"/>
           <p:cNvSpPr/>
           <p:nvPr/>
         </p:nvSpPr>
@@ -12612,7 +12388,7 @@
       </p:sp>
       <p:sp>
         <p:nvSpPr>
-          <p:cNvPr id="10" name="Next title"/>
+          <p:cNvPr id="10" name="Future improvements title"/>
           <p:cNvSpPr txBox="1"/>
           <p:nvPr/>
         </p:nvSpPr>
@@ -12642,7 +12418,7 @@
                   <a:schemeClr val="bg2"/>
                 </a:solidFill>
               </a:rPr>
-              <a:t>Next</a:t>
+              <a:t>Future improvements</a:t>
             </a:r>
             <a:endParaRPr lang="en-US" sz="1300" dirty="0"/>
           </a:p>
@@ -12650,7 +12426,7 @@
       </p:sp>
       <p:sp>
         <p:nvSpPr>
-          <p:cNvPr id="11" name="Next text"/>
+          <p:cNvPr id="11" name="Future improvements text"/>
           <p:cNvSpPr txBox="1"/>
           <p:nvPr/>
         </p:nvSpPr>

</xml_diff>

<commit_message>
docs(slides): appendix divider, repo link, plainer stage 2 takeaway
- Title slide: GitHub repo link
- Appendix section slide before the backup slides
- Comparison table: "Why it matters" column renamed "Comment"
- Stage 2: drop k = 2 bullet, rewrite takeaway in plain words
- Per subject: move takeaway box up under the bullets

Co-Authored-By: Claude Opus 5.5 <noreply@anthropic.com>
</commit_message>
<xml_diff>
--- a/docs/final_slides/HWNet_Final_Presentation.pptx
+++ b/docs/final_slides/HWNet_Final_Presentation.pptx
@@ -19,14 +19,15 @@
     <p:sldId id="273" r:id="rId24"/>
     <p:sldId id="274" r:id="rId25"/>
     <p:sldId id="275" r:id="rId26"/>
+    <p:sldId id="276" r:id="rId27"/>
     <p:sldId id="262" r:id="rId8"/>
     <p:sldId id="263" r:id="rId9"/>
     <p:sldId id="264" r:id="rId10"/>
     <p:sldId id="265" r:id="rId11"/>
     <p:sldId id="266" r:id="rId12"/>
     <p:sldId id="267" r:id="rId13"/>
-    <p:sldId id="276" r:id="rId27"/>
     <p:sldId id="277" r:id="rId28"/>
+    <p:sldId id="278" r:id="rId29"/>
   </p:sldIdLst>
   <p:notesMasterIdLst>
     <p:notesMasterId r:id="rId14"/>
@@ -2678,6 +2679,94 @@
 </p:notes>
 </file>
 
+<file path=ppt/notesSlides/notesSlide23.xml><?xml version="1.0" encoding="utf-8"?>
+<p:notes xmlns:a="http://schemas.openxmlformats.org/drawingml/2006/main" xmlns:r="http://schemas.openxmlformats.org/officeDocument/2006/relationships" xmlns:p="http://schemas.openxmlformats.org/presentationml/2006/main">
+  <p:cSld>
+    <p:spTree>
+      <p:nvGrpSpPr>
+        <p:cNvPr id="1" name=""/>
+        <p:cNvGrpSpPr/>
+        <p:nvPr/>
+      </p:nvGrpSpPr>
+      <p:grpSpPr>
+        <a:xfrm>
+          <a:off x="0" y="0"/>
+          <a:ext cx="0" cy="0"/>
+          <a:chOff x="0" y="0"/>
+          <a:chExt cx="0" cy="0"/>
+        </a:xfrm>
+      </p:grpSpPr>
+      <p:sp>
+        <p:nvSpPr>
+          <p:cNvPr id="2" name="Slide Image Placeholder 1"/>
+          <p:cNvSpPr>
+            <a:spLocks noGrp="1" noRot="1" noChangeAspect="1"/>
+          </p:cNvSpPr>
+          <p:nvPr>
+            <p:ph type="sldImg"/>
+          </p:nvPr>
+        </p:nvSpPr>
+        <p:spPr/>
+      </p:sp>
+      <p:sp>
+        <p:nvSpPr>
+          <p:cNvPr id="3" name="Notes Placeholder 2"/>
+          <p:cNvSpPr>
+            <a:spLocks noGrp="1"/>
+          </p:cNvSpPr>
+          <p:nvPr>
+            <p:ph type="body" idx="1"/>
+          </p:nvPr>
+        </p:nvSpPr>
+        <p:spPr/>
+        <p:txBody>
+          <a:bodyPr/>
+          <a:lstStyle/>
+          <a:p>
+            <a:r>
+              <a:rPr lang="en-US" dirty="0"/>
+              <a:t/>
+            </a:r>
+            <a:endParaRPr lang="en-US" dirty="0"/>
+          </a:p>
+        </p:txBody>
+      </p:sp>
+      <p:sp>
+        <p:nvSpPr>
+          <p:cNvPr id="4" name="Slide Number Placeholder 3"/>
+          <p:cNvSpPr>
+            <a:spLocks noGrp="1"/>
+          </p:cNvSpPr>
+          <p:nvPr>
+            <p:ph type="sldNum" sz="quarter" idx="10"/>
+          </p:nvPr>
+        </p:nvSpPr>
+        <p:spPr/>
+        <p:txBody>
+          <a:bodyPr/>
+          <a:lstStyle/>
+          <a:p>
+            <a:fld id="{F7021451-1387-4CA6-816F-3879F97B5CBC}" type="slidenum">
+              <a:rPr lang="en-US"/>
+              <a:t>11</a:t>
+            </a:fld>
+            <a:endParaRPr lang="en-US"/>
+          </a:p>
+        </p:txBody>
+      </p:sp>
+    </p:spTree>
+    <p:extLst>
+      <p:ext uri="{BB962C8B-B14F-4D97-AF65-F5344CB8AC3E}">
+        <p14:creationId xmlns:p14="http://schemas.microsoft.com/office/powerpoint/2010/main" val="1024086991"/>
+      </p:ext>
+    </p:extLst>
+  </p:cSld>
+  <p:clrMapOvr>
+    <a:masterClrMapping/>
+  </p:clrMapOvr>
+</p:notes>
+</file>
+
 <file path=ppt/notesSlides/notesSlide3.xml><?xml version="1.0" encoding="utf-8"?>
 <p:notes xmlns:a="http://schemas.openxmlformats.org/drawingml/2006/main" xmlns:r="http://schemas.openxmlformats.org/officeDocument/2006/relationships" xmlns:p="http://schemas.openxmlformats.org/presentationml/2006/main">
   <p:cSld>
@@ -3992,6 +4081,43 @@
           </a:p>
         </p:txBody>
       </p:sp>
+      <p:sp>
+        <p:nvSpPr>
+          <p:cNvPr id="6" name="Repo link"/>
+          <p:cNvSpPr txBox="1"/>
+          <p:nvPr/>
+        </p:nvSpPr>
+        <p:spPr>
+          <a:xfrm>
+            <a:off x="548640" y="3291840"/>
+            <a:ext cx="8046720" cy="320040"/>
+          </a:xfrm>
+          <a:prstGeom prst="rect">
+            <a:avLst/>
+          </a:prstGeom>
+          <a:noFill/>
+          <a:ln/>
+        </p:spPr>
+        <p:txBody>
+          <a:bodyPr wrap="square" lIns="0" tIns="0" rIns="0" bIns="0" rtlCol="0" anchor="t"/>
+          <a:lstStyle/>
+          <a:p>
+            <a:pPr indent="0" marL="0">
+              <a:buNone/>
+            </a:pPr>
+            <a:r>
+              <a:rPr lang="en-US" sz="1100" dirty="0">
+                <a:solidFill>
+                  <a:schemeClr val="accent1"/>
+                </a:solidFill>
+                <a:hlinkClick r:id="rId3"/>
+              </a:rPr>
+              <a:t>https://github.com/pratch/frontier-hw-bci</a:t>
+            </a:r>
+            <a:endParaRPr lang="en-US" sz="1100" dirty="0"/>
+          </a:p>
+        </p:txBody>
+      </p:sp>
     </p:spTree>
   </p:cSld>
   <p:clrMapOvr>
@@ -6102,7 +6228,7 @@
                             <a:schemeClr val="tx1"/>
                           </a:solidFill>
                         </a:rPr>
-                        <a:t>Why it matters</a:t>
+                        <a:t>Comment</a:t>
                       </a:r>
                       <a:endParaRPr lang="en-US" sz="1200" dirty="0"/>
                     </a:p>
@@ -8955,32 +9081,6 @@
             </a:r>
             <a:endParaRPr lang="en-US" sz="1250" dirty="0"/>
           </a:p>
-          <a:p>
-            <a:pPr marL="152400" indent="-152400">
-              <a:spcAft>
-                <a:spcPts val="600"/>
-              </a:spcAft>
-              <a:buSzPct val="100000"/>
-              <a:buChar char="•"/>
-            </a:pPr>
-            <a:r>
-              <a:rPr lang="en-US" sz="1250" dirty="0">
-                <a:solidFill>
-                  <a:schemeClr val="tx1"/>
-                </a:solidFill>
-              </a:rPr>
-              <a:t>k = 2 (0.75 s) is last on both metrics: </a:t>
-            </a:r>
-            <a:r>
-              <a:rPr lang="en-US" sz="1250" dirty="0">
-                <a:solidFill>
-                  <a:schemeClr val="accent4"/>
-                </a:solidFill>
-              </a:rPr>
-              <a:t>too little context</a:t>
-            </a:r>
-            <a:endParaRPr lang="en-US" sz="1250" dirty="0"/>
-          </a:p>
         </p:txBody>
       </p:sp>
       <p:sp>
@@ -9175,23 +9275,7 @@
                   <a:schemeClr val="tx1"/>
                 </a:solidFill>
               </a:rPr>
-              <a:t>The top 3 are within </a:t>
-            </a:r>
-            <a:r>
-              <a:rPr lang="en-US" sz="1250" dirty="0">
-                <a:solidFill>
-                  <a:schemeClr val="accent4"/>
-                </a:solidFill>
-              </a:rPr>
-              <a:t>0.4 pp</a:t>
-            </a:r>
-            <a:r>
-              <a:rPr lang="en-US" sz="1250" dirty="0">
-                <a:solidFill>
-                  <a:schemeClr val="tx1"/>
-                </a:solidFill>
-              </a:rPr>
-              <a:t>. Tuning confirms the first design (k = 3, dropout 0.5) rather than replacing it.</a:t>
+              <a:t>The top 3 differ by less than 0.4 pp. Our original setup (k = 3, dropout 0.5) was already the best, so we kept it.</a:t>
             </a:r>
             <a:endParaRPr lang="en-US" sz="1250" dirty="0"/>
           </a:p>
@@ -10641,7 +10725,7 @@
         <p:spPr>
           <a:xfrm>
             <a:off x="5440680" y="685800"/>
-            <a:ext cx="3291840" cy="2606040"/>
+            <a:ext cx="3291840" cy="1828800"/>
           </a:xfrm>
           <a:prstGeom prst="rect">
             <a:avLst/>
@@ -10756,7 +10840,7 @@
         </p:nvSpPr>
         <p:spPr>
           <a:xfrm>
-            <a:off x="5440680" y="3474720"/>
+            <a:off x="5440680" y="2697480"/>
             <a:ext cx="3291840" cy="960120"/>
           </a:xfrm>
           <a:prstGeom prst="rect">
@@ -10778,7 +10862,7 @@
         </p:nvSpPr>
         <p:spPr>
           <a:xfrm>
-            <a:off x="5440680" y="3474720"/>
+            <a:off x="5440680" y="2697480"/>
             <a:ext cx="3291840" cy="274320"/>
           </a:xfrm>
           <a:prstGeom prst="rect">
@@ -10816,7 +10900,7 @@
         </p:nvSpPr>
         <p:spPr>
           <a:xfrm>
-            <a:off x="5477256" y="3785616"/>
+            <a:off x="5477256" y="3008376"/>
             <a:ext cx="3218688" cy="612648"/>
           </a:xfrm>
           <a:prstGeom prst="rect">
@@ -12553,6 +12637,107 @@
         </p:nvSpPr>
         <p:spPr>
           <a:xfrm>
+            <a:off x="548640" y="1371600"/>
+            <a:ext cx="8046720" cy="548640"/>
+          </a:xfrm>
+          <a:prstGeom prst="rect">
+            <a:avLst/>
+          </a:prstGeom>
+          <a:noFill/>
+          <a:ln/>
+        </p:spPr>
+        <p:txBody>
+          <a:bodyPr wrap="square" lIns="0" tIns="0" rIns="0" bIns="0" rtlCol="0" anchor="b"/>
+          <a:lstStyle/>
+          <a:p>
+            <a:pPr indent="0" marL="0">
+              <a:buNone/>
+            </a:pPr>
+            <a:r>
+              <a:rPr lang="en-US" sz="2600" b="1" dirty="0">
+                <a:solidFill>
+                  <a:schemeClr val="tx1"/>
+                </a:solidFill>
+              </a:rPr>
+              <a:t>Appendix</a:t>
+            </a:r>
+            <a:endParaRPr lang="en-US" sz="2600" dirty="0"/>
+          </a:p>
+        </p:txBody>
+      </p:sp>
+      <p:sp>
+        <p:nvSpPr>
+          <p:cNvPr id="3" name="Text 1"/>
+          <p:cNvSpPr/>
+          <p:nvPr>
+            <p:ph idx="102" type="body" hasCustomPrompt="1"/>
+          </p:nvPr>
+        </p:nvSpPr>
+        <p:spPr>
+          <a:xfrm>
+            <a:off x="548640" y="1938528"/>
+            <a:ext cx="8046720" cy="411480"/>
+          </a:xfrm>
+          <a:prstGeom prst="rect">
+            <a:avLst/>
+          </a:prstGeom>
+          <a:noFill/>
+          <a:ln/>
+        </p:spPr>
+        <p:txBody>
+          <a:bodyPr wrap="square" lIns="0" tIns="0" rIns="0" bIns="0" rtlCol="0" anchor="t"/>
+          <a:lstStyle/>
+          <a:p>
+            <a:pPr indent="0" marL="0">
+              <a:buNone/>
+            </a:pPr>
+            <a:r>
+              <a:rPr lang="en-US" sz="1700" dirty="0">
+                <a:solidFill>
+                  <a:schemeClr val="tx1"/>
+                </a:solidFill>
+              </a:rPr>
+              <a:t>Backup slides: preprocessing details and model results</a:t>
+            </a:r>
+            <a:endParaRPr lang="en-US" sz="1700" dirty="0"/>
+          </a:p>
+        </p:txBody>
+      </p:sp>
+    </p:spTree>
+  </p:cSld>
+  <p:clrMapOvr>
+    <a:masterClrMapping/>
+  </p:clrMapOvr>
+</p:sld>
+</file>
+
+<file path=ppt/slides/slide22.xml><?xml version="1.0" encoding="utf-8"?>
+<p:sld xmlns:a="http://schemas.openxmlformats.org/drawingml/2006/main" xmlns:r="http://schemas.openxmlformats.org/officeDocument/2006/relationships" xmlns:p="http://schemas.openxmlformats.org/presentationml/2006/main">
+  <p:cSld name="Slide 10">
+    <p:spTree>
+      <p:nvGrpSpPr>
+        <p:cNvPr id="1" name=""/>
+        <p:cNvGrpSpPr/>
+        <p:nvPr/>
+      </p:nvGrpSpPr>
+      <p:grpSpPr>
+        <a:xfrm>
+          <a:off x="0" y="0"/>
+          <a:ext cx="0" cy="0"/>
+          <a:chOff x="0" y="0"/>
+          <a:chExt cx="0" cy="0"/>
+        </a:xfrm>
+      </p:grpSpPr>
+      <p:sp>
+        <p:nvSpPr>
+          <p:cNvPr id="2" name="Text 1"/>
+          <p:cNvSpPr/>
+          <p:nvPr>
+            <p:ph idx="101" type="title" hasCustomPrompt="1"/>
+          </p:nvPr>
+        </p:nvSpPr>
+        <p:spPr>
+          <a:xfrm>
             <a:off x="320040" y="0"/>
             <a:ext cx="8503920" cy="502920"/>
           </a:xfrm>
@@ -12583,7 +12768,7 @@
       </p:sp>
       <p:graphicFrame>
         <p:nvGraphicFramePr>
-          <p:cNvPr id="10" name="Table 0"/>
+          <p:cNvPr id="11" name="Table 0"/>
           <p:cNvGraphicFramePr>
             <a:graphicFrameLocks noGrp="1"/>
           </p:cNvGraphicFramePr>
@@ -14132,9 +14317,9 @@
 </p:sld>
 </file>
 
-<file path=ppt/slides/slide22.xml><?xml version="1.0" encoding="utf-8"?>
+<file path=ppt/slides/slide23.xml><?xml version="1.0" encoding="utf-8"?>
 <p:sld xmlns:a="http://schemas.openxmlformats.org/drawingml/2006/main" xmlns:r="http://schemas.openxmlformats.org/officeDocument/2006/relationships" xmlns:p="http://schemas.openxmlformats.org/presentationml/2006/main">
-  <p:cSld name="Slide 10">
+  <p:cSld name="Slide 11">
     <p:spTree>
       <p:nvGrpSpPr>
         <p:cNvPr id="1" name=""/>
@@ -14189,7 +14374,7 @@
       </p:sp>
       <p:graphicFrame>
         <p:nvGraphicFramePr>
-          <p:cNvPr id="11" name="Table 0"/>
+          <p:cNvPr id="12" name="Table 0"/>
           <p:cNvGraphicFramePr>
             <a:graphicFrameLocks noGrp="1"/>
           </p:cNvGraphicFramePr>

</xml_diff>